<commit_message>
Fix manual prediction upsert and add cascade delete trigger
</commit_message>
<xml_diff>
--- a/placement app/docs/PlacementAI_Presentation.pptx
+++ b/placement app/docs/PlacementAI_Presentation.pptx
@@ -12,8 +12,11 @@
     <p:sldId id="260" r:id="rId6"/>
     <p:sldId id="261" r:id="rId7"/>
     <p:sldId id="262" r:id="rId8"/>
-    <p:sldId id="263" r:id="rId9"/>
-    <p:sldId id="264" r:id="rId10"/>
+    <p:sldId id="265" r:id="rId9"/>
+    <p:sldId id="266" r:id="rId10"/>
+    <p:sldId id="267" r:id="rId11"/>
+    <p:sldId id="263" r:id="rId12"/>
+    <p:sldId id="264" r:id="rId13"/>
   </p:sldIdLst>
   <p:sldSz cx="9144000" cy="6858000" type="screen4x3"/>
   <p:notesSz cx="6858000" cy="9144000"/>
@@ -469,7 +472,7 @@
           <a:p>
             <a:fld id="{5BCAD085-E8A6-8845-BD4E-CB4CCA059FC4}" type="datetimeFigureOut">
               <a:rPr lang="en-US" smtClean="0"/>
-              <a:t>4/30/2026</a:t>
+              <a:t>5/11/2026</a:t>
             </a:fld>
             <a:endParaRPr lang="en-US"/>
           </a:p>
@@ -793,7 +796,7 @@
           <a:p>
             <a:fld id="{5BCAD085-E8A6-8845-BD4E-CB4CCA059FC4}" type="datetimeFigureOut">
               <a:rPr lang="en-US" smtClean="0"/>
-              <a:t>4/30/2026</a:t>
+              <a:t>5/11/2026</a:t>
             </a:fld>
             <a:endParaRPr lang="en-US"/>
           </a:p>
@@ -1041,7 +1044,7 @@
           <a:p>
             <a:fld id="{5BCAD085-E8A6-8845-BD4E-CB4CCA059FC4}" type="datetimeFigureOut">
               <a:rPr lang="en-US" smtClean="0"/>
-              <a:t>4/30/2026</a:t>
+              <a:t>5/11/2026</a:t>
             </a:fld>
             <a:endParaRPr lang="en-US"/>
           </a:p>
@@ -1380,7 +1383,7 @@
           <a:p>
             <a:fld id="{5BCAD085-E8A6-8845-BD4E-CB4CCA059FC4}" type="datetimeFigureOut">
               <a:rPr lang="en-US" smtClean="0"/>
-              <a:t>4/30/2026</a:t>
+              <a:t>5/11/2026</a:t>
             </a:fld>
             <a:endParaRPr lang="en-US"/>
           </a:p>
@@ -1727,7 +1730,7 @@
           <a:p>
             <a:fld id="{5BCAD085-E8A6-8845-BD4E-CB4CCA059FC4}" type="datetimeFigureOut">
               <a:rPr lang="en-US" smtClean="0"/>
-              <a:t>4/30/2026</a:t>
+              <a:t>5/11/2026</a:t>
             </a:fld>
             <a:endParaRPr lang="en-US"/>
           </a:p>
@@ -2101,7 +2104,7 @@
           <a:p>
             <a:fld id="{5BCAD085-E8A6-8845-BD4E-CB4CCA059FC4}" type="datetimeFigureOut">
               <a:rPr lang="en-US" smtClean="0"/>
-              <a:t>4/30/2026</a:t>
+              <a:t>5/11/2026</a:t>
             </a:fld>
             <a:endParaRPr lang="en-US"/>
           </a:p>
@@ -2571,7 +2574,7 @@
           <a:p>
             <a:fld id="{5BCAD085-E8A6-8845-BD4E-CB4CCA059FC4}" type="datetimeFigureOut">
               <a:rPr lang="en-US" smtClean="0"/>
-              <a:t>4/30/2026</a:t>
+              <a:t>5/11/2026</a:t>
             </a:fld>
             <a:endParaRPr lang="en-US"/>
           </a:p>
@@ -2781,7 +2784,7 @@
           <a:p>
             <a:fld id="{5BCAD085-E8A6-8845-BD4E-CB4CCA059FC4}" type="datetimeFigureOut">
               <a:rPr lang="en-US" smtClean="0"/>
-              <a:t>4/30/2026</a:t>
+              <a:t>5/11/2026</a:t>
             </a:fld>
             <a:endParaRPr lang="en-US"/>
           </a:p>
@@ -2992,7 +2995,7 @@
           <a:p>
             <a:fld id="{5BCAD085-E8A6-8845-BD4E-CB4CCA059FC4}" type="datetimeFigureOut">
               <a:rPr lang="en-US" smtClean="0"/>
-              <a:t>4/30/2026</a:t>
+              <a:t>5/11/2026</a:t>
             </a:fld>
             <a:endParaRPr lang="en-US"/>
           </a:p>
@@ -3224,7 +3227,7 @@
           <a:p>
             <a:fld id="{5BCAD085-E8A6-8845-BD4E-CB4CCA059FC4}" type="datetimeFigureOut">
               <a:rPr lang="en-US" smtClean="0"/>
-              <a:t>4/30/2026</a:t>
+              <a:t>5/11/2026</a:t>
             </a:fld>
             <a:endParaRPr lang="en-US"/>
           </a:p>
@@ -3472,7 +3475,7 @@
           <a:p>
             <a:fld id="{5BCAD085-E8A6-8845-BD4E-CB4CCA059FC4}" type="datetimeFigureOut">
               <a:rPr lang="en-US" smtClean="0"/>
-              <a:t>4/30/2026</a:t>
+              <a:t>5/11/2026</a:t>
             </a:fld>
             <a:endParaRPr lang="en-US"/>
           </a:p>
@@ -3775,7 +3778,7 @@
           <a:p>
             <a:fld id="{5BCAD085-E8A6-8845-BD4E-CB4CCA059FC4}" type="datetimeFigureOut">
               <a:rPr lang="en-US" smtClean="0"/>
-              <a:t>4/30/2026</a:t>
+              <a:t>5/11/2026</a:t>
             </a:fld>
             <a:endParaRPr lang="en-US"/>
           </a:p>
@@ -4157,7 +4160,7 @@
           <a:p>
             <a:fld id="{5BCAD085-E8A6-8845-BD4E-CB4CCA059FC4}" type="datetimeFigureOut">
               <a:rPr lang="en-US" smtClean="0"/>
-              <a:t>4/30/2026</a:t>
+              <a:t>5/11/2026</a:t>
             </a:fld>
             <a:endParaRPr lang="en-US"/>
           </a:p>
@@ -4311,7 +4314,7 @@
           <a:p>
             <a:fld id="{5BCAD085-E8A6-8845-BD4E-CB4CCA059FC4}" type="datetimeFigureOut">
               <a:rPr lang="en-US" smtClean="0"/>
-              <a:t>4/30/2026</a:t>
+              <a:t>5/11/2026</a:t>
             </a:fld>
             <a:endParaRPr lang="en-US"/>
           </a:p>
@@ -4437,7 +4440,7 @@
           <a:p>
             <a:fld id="{5BCAD085-E8A6-8845-BD4E-CB4CCA059FC4}" type="datetimeFigureOut">
               <a:rPr lang="en-US" smtClean="0"/>
-              <a:t>4/30/2026</a:t>
+              <a:t>5/11/2026</a:t>
             </a:fld>
             <a:endParaRPr lang="en-US"/>
           </a:p>
@@ -4692,7 +4695,7 @@
           <a:p>
             <a:fld id="{5BCAD085-E8A6-8845-BD4E-CB4CCA059FC4}" type="datetimeFigureOut">
               <a:rPr lang="en-US" smtClean="0"/>
-              <a:t>4/30/2026</a:t>
+              <a:t>5/11/2026</a:t>
             </a:fld>
             <a:endParaRPr lang="en-US"/>
           </a:p>
@@ -5006,7 +5009,7 @@
           <a:p>
             <a:fld id="{5BCAD085-E8A6-8845-BD4E-CB4CCA059FC4}" type="datetimeFigureOut">
               <a:rPr lang="en-US" smtClean="0"/>
-              <a:t>4/30/2026</a:t>
+              <a:t>5/11/2026</a:t>
             </a:fld>
             <a:endParaRPr lang="en-US"/>
           </a:p>
@@ -5364,7 +5367,7 @@
           <a:p>
             <a:fld id="{5BCAD085-E8A6-8845-BD4E-CB4CCA059FC4}" type="datetimeFigureOut">
               <a:rPr lang="en-US" smtClean="0"/>
-              <a:t>4/30/2026</a:t>
+              <a:t>5/11/2026</a:t>
             </a:fld>
             <a:endParaRPr lang="en-US"/>
           </a:p>
@@ -5920,13 +5923,15 @@
         <p:spPr/>
         <p:txBody>
           <a:bodyPr>
-            <a:normAutofit fontScale="90000"/>
+            <a:normAutofit/>
           </a:bodyPr>
           <a:lstStyle/>
           <a:p>
             <a:r>
-              <a:t>PlacementAI: Intelligent Student Placement Prediction</a:t>
-            </a:r>
+              <a:rPr lang="en-US" sz="2800" b="1" dirty="0"/>
+              <a:t>STUDENT PLACEMENT PREDICTION SYSTEM USING MACHINE LEARNING</a:t>
+            </a:r>
+            <a:endParaRPr lang="en-IN" sz="2800" b="1" dirty="0"/>
           </a:p>
         </p:txBody>
       </p:sp>
@@ -5961,6 +5966,225 @@
             <a:r>
               <a:rPr dirty="0"/>
               <a:t>Presenter: Pratik Mohite</a:t>
+            </a:r>
+          </a:p>
+        </p:txBody>
+      </p:sp>
+    </p:spTree>
+  </p:cSld>
+  <p:clrMapOvr>
+    <a:masterClrMapping/>
+  </p:clrMapOvr>
+</p:sld>
+</file>
+
+<file path=ppt/slides/slide10.xml><?xml version="1.0" encoding="utf-8"?>
+<p:sld xmlns:a="http://schemas.openxmlformats.org/drawingml/2006/main" xmlns:r="http://schemas.openxmlformats.org/officeDocument/2006/relationships" xmlns:p="http://schemas.openxmlformats.org/presentationml/2006/main">
+  <p:cSld>
+    <p:spTree>
+      <p:nvGrpSpPr>
+        <p:cNvPr id="1" name=""/>
+        <p:cNvGrpSpPr/>
+        <p:nvPr/>
+      </p:nvGrpSpPr>
+      <p:grpSpPr>
+        <a:xfrm>
+          <a:off x="0" y="0"/>
+          <a:ext cx="0" cy="0"/>
+          <a:chOff x="0" y="0"/>
+          <a:chExt cx="0" cy="0"/>
+        </a:xfrm>
+      </p:grpSpPr>
+      <p:pic>
+        <p:nvPicPr>
+          <p:cNvPr id="3" name="Picture 2">
+            <a:extLst>
+              <a:ext uri="{FF2B5EF4-FFF2-40B4-BE49-F238E27FC236}">
+                <a16:creationId xmlns:a16="http://schemas.microsoft.com/office/drawing/2014/main" id="{DCBE3230-D44E-16B0-D723-6A523497DBF9}"/>
+              </a:ext>
+            </a:extLst>
+          </p:cNvPr>
+          <p:cNvPicPr>
+            <a:picLocks noChangeAspect="1"/>
+          </p:cNvPicPr>
+          <p:nvPr/>
+        </p:nvPicPr>
+        <p:blipFill>
+          <a:blip r:embed="rId2"/>
+          <a:stretch>
+            <a:fillRect/>
+          </a:stretch>
+        </p:blipFill>
+        <p:spPr>
+          <a:xfrm>
+            <a:off x="737419" y="706847"/>
+            <a:ext cx="7660722" cy="5438314"/>
+          </a:xfrm>
+          <a:prstGeom prst="rect">
+            <a:avLst/>
+          </a:prstGeom>
+        </p:spPr>
+      </p:pic>
+    </p:spTree>
+    <p:extLst>
+      <p:ext uri="{BB962C8B-B14F-4D97-AF65-F5344CB8AC3E}">
+        <p14:creationId xmlns:p14="http://schemas.microsoft.com/office/powerpoint/2010/main" val="819465193"/>
+      </p:ext>
+    </p:extLst>
+  </p:cSld>
+  <p:clrMapOvr>
+    <a:masterClrMapping/>
+  </p:clrMapOvr>
+</p:sld>
+</file>
+
+<file path=ppt/slides/slide11.xml><?xml version="1.0" encoding="utf-8"?>
+<p:sld xmlns:a="http://schemas.openxmlformats.org/drawingml/2006/main" xmlns:r="http://schemas.openxmlformats.org/officeDocument/2006/relationships" xmlns:p="http://schemas.openxmlformats.org/presentationml/2006/main">
+  <p:cSld>
+    <p:spTree>
+      <p:nvGrpSpPr>
+        <p:cNvPr id="1" name=""/>
+        <p:cNvGrpSpPr/>
+        <p:nvPr/>
+      </p:nvGrpSpPr>
+      <p:grpSpPr>
+        <a:xfrm>
+          <a:off x="0" y="0"/>
+          <a:ext cx="0" cy="0"/>
+          <a:chOff x="0" y="0"/>
+          <a:chExt cx="0" cy="0"/>
+        </a:xfrm>
+      </p:grpSpPr>
+      <p:sp>
+        <p:nvSpPr>
+          <p:cNvPr id="2" name="Title 1"/>
+          <p:cNvSpPr>
+            <a:spLocks noGrp="1"/>
+          </p:cNvSpPr>
+          <p:nvPr>
+            <p:ph type="title"/>
+          </p:nvPr>
+        </p:nvSpPr>
+        <p:spPr/>
+        <p:txBody>
+          <a:bodyPr/>
+          <a:lstStyle/>
+          <a:p>
+            <a:r>
+              <a:t>Future Enhancements</a:t>
+            </a:r>
+          </a:p>
+        </p:txBody>
+      </p:sp>
+      <p:sp>
+        <p:nvSpPr>
+          <p:cNvPr id="3" name="Content Placeholder 2"/>
+          <p:cNvSpPr>
+            <a:spLocks noGrp="1"/>
+          </p:cNvSpPr>
+          <p:nvPr>
+            <p:ph idx="1"/>
+          </p:nvPr>
+        </p:nvSpPr>
+        <p:spPr/>
+        <p:txBody>
+          <a:bodyPr/>
+          <a:lstStyle/>
+          <a:p>
+            <a:r>
+              <a:t>• Student login system</a:t>
+            </a:r>
+          </a:p>
+          <a:p>
+            <a:r>
+              <a:t>• Job role prediction</a:t>
+            </a:r>
+          </a:p>
+          <a:p>
+            <a:r>
+              <a:t>• Email integration</a:t>
+            </a:r>
+          </a:p>
+        </p:txBody>
+      </p:sp>
+    </p:spTree>
+  </p:cSld>
+  <p:clrMapOvr>
+    <a:masterClrMapping/>
+  </p:clrMapOvr>
+</p:sld>
+</file>
+
+<file path=ppt/slides/slide12.xml><?xml version="1.0" encoding="utf-8"?>
+<p:sld xmlns:a="http://schemas.openxmlformats.org/drawingml/2006/main" xmlns:r="http://schemas.openxmlformats.org/officeDocument/2006/relationships" xmlns:p="http://schemas.openxmlformats.org/presentationml/2006/main">
+  <p:cSld>
+    <p:spTree>
+      <p:nvGrpSpPr>
+        <p:cNvPr id="1" name=""/>
+        <p:cNvGrpSpPr/>
+        <p:nvPr/>
+      </p:nvGrpSpPr>
+      <p:grpSpPr>
+        <a:xfrm>
+          <a:off x="0" y="0"/>
+          <a:ext cx="0" cy="0"/>
+          <a:chOff x="0" y="0"/>
+          <a:chExt cx="0" cy="0"/>
+        </a:xfrm>
+      </p:grpSpPr>
+      <p:sp>
+        <p:nvSpPr>
+          <p:cNvPr id="2" name="Title 1"/>
+          <p:cNvSpPr>
+            <a:spLocks noGrp="1"/>
+          </p:cNvSpPr>
+          <p:nvPr>
+            <p:ph type="title"/>
+          </p:nvPr>
+        </p:nvSpPr>
+        <p:spPr/>
+        <p:txBody>
+          <a:bodyPr/>
+          <a:lstStyle/>
+          <a:p>
+            <a:r>
+              <a:t>Conclusion</a:t>
+            </a:r>
+          </a:p>
+        </p:txBody>
+      </p:sp>
+      <p:sp>
+        <p:nvSpPr>
+          <p:cNvPr id="3" name="Content Placeholder 2"/>
+          <p:cNvSpPr>
+            <a:spLocks noGrp="1"/>
+          </p:cNvSpPr>
+          <p:nvPr>
+            <p:ph idx="1"/>
+          </p:nvPr>
+        </p:nvSpPr>
+        <p:spPr/>
+        <p:txBody>
+          <a:bodyPr/>
+          <a:lstStyle/>
+          <a:p>
+            <a:r>
+              <a:rPr dirty="0"/>
+              <a:t>• Converts data into insights</a:t>
+            </a:r>
+          </a:p>
+          <a:p>
+            <a:r>
+              <a:rPr dirty="0"/>
+              <a:t>• Improves placement </a:t>
+            </a:r>
+            <a:r>
+              <a:rPr dirty="0" err="1"/>
+              <a:t>readines</a:t>
+            </a:r>
+            <a:r>
+              <a:rPr lang="en-IN" dirty="0"/>
+              <a:t>s</a:t>
             </a:r>
           </a:p>
         </p:txBody>
@@ -6459,59 +6683,102 @@
           <a:chExt cx="0" cy="0"/>
         </a:xfrm>
       </p:grpSpPr>
-      <p:sp>
-        <p:nvSpPr>
-          <p:cNvPr id="2" name="Title 1"/>
-          <p:cNvSpPr>
-            <a:spLocks noGrp="1"/>
-          </p:cNvSpPr>
-          <p:nvPr>
-            <p:ph type="title"/>
-          </p:nvPr>
-        </p:nvSpPr>
-        <p:spPr/>
-        <p:txBody>
-          <a:bodyPr/>
-          <a:lstStyle/>
-          <a:p>
-            <a:r>
-              <a:t>Future Enhancements</a:t>
-            </a:r>
-          </a:p>
-        </p:txBody>
-      </p:sp>
-      <p:sp>
-        <p:nvSpPr>
-          <p:cNvPr id="3" name="Content Placeholder 2"/>
-          <p:cNvSpPr>
-            <a:spLocks noGrp="1"/>
-          </p:cNvSpPr>
-          <p:nvPr>
-            <p:ph idx="1"/>
-          </p:nvPr>
-        </p:nvSpPr>
-        <p:spPr/>
-        <p:txBody>
-          <a:bodyPr/>
-          <a:lstStyle/>
-          <a:p>
-            <a:r>
-              <a:t>• Student login system</a:t>
-            </a:r>
-          </a:p>
-          <a:p>
-            <a:r>
-              <a:t>• Job role prediction</a:t>
-            </a:r>
-          </a:p>
-          <a:p>
-            <a:r>
-              <a:t>• Email integration</a:t>
-            </a:r>
-          </a:p>
-        </p:txBody>
-      </p:sp>
+      <p:pic>
+        <p:nvPicPr>
+          <p:cNvPr id="3" name="Picture 2">
+            <a:extLst>
+              <a:ext uri="{FF2B5EF4-FFF2-40B4-BE49-F238E27FC236}">
+                <a16:creationId xmlns:a16="http://schemas.microsoft.com/office/drawing/2014/main" id="{82D61F30-AD4B-68A2-60A4-923709E44A94}"/>
+              </a:ext>
+            </a:extLst>
+          </p:cNvPr>
+          <p:cNvPicPr>
+            <a:picLocks noChangeAspect="1"/>
+          </p:cNvPicPr>
+          <p:nvPr/>
+        </p:nvPicPr>
+        <p:blipFill>
+          <a:blip r:embed="rId2"/>
+          <a:stretch>
+            <a:fillRect/>
+          </a:stretch>
+        </p:blipFill>
+        <p:spPr>
+          <a:xfrm>
+            <a:off x="607960" y="648948"/>
+            <a:ext cx="7794360" cy="3028317"/>
+          </a:xfrm>
+          <a:prstGeom prst="rect">
+            <a:avLst/>
+          </a:prstGeom>
+        </p:spPr>
+      </p:pic>
+      <p:pic>
+        <p:nvPicPr>
+          <p:cNvPr id="5" name="Picture 4">
+            <a:extLst>
+              <a:ext uri="{FF2B5EF4-FFF2-40B4-BE49-F238E27FC236}">
+                <a16:creationId xmlns:a16="http://schemas.microsoft.com/office/drawing/2014/main" id="{E2BBA977-AAA8-68CB-F6BF-E1EBB049CD95}"/>
+              </a:ext>
+            </a:extLst>
+          </p:cNvPr>
+          <p:cNvPicPr>
+            <a:picLocks noChangeAspect="1"/>
+          </p:cNvPicPr>
+          <p:nvPr/>
+        </p:nvPicPr>
+        <p:blipFill>
+          <a:blip r:embed="rId3"/>
+          <a:stretch>
+            <a:fillRect/>
+          </a:stretch>
+        </p:blipFill>
+        <p:spPr>
+          <a:xfrm>
+            <a:off x="607961" y="3780177"/>
+            <a:ext cx="3964040" cy="2428875"/>
+          </a:xfrm>
+          <a:prstGeom prst="rect">
+            <a:avLst/>
+          </a:prstGeom>
+        </p:spPr>
+      </p:pic>
+      <p:pic>
+        <p:nvPicPr>
+          <p:cNvPr id="7" name="Picture 6">
+            <a:extLst>
+              <a:ext uri="{FF2B5EF4-FFF2-40B4-BE49-F238E27FC236}">
+                <a16:creationId xmlns:a16="http://schemas.microsoft.com/office/drawing/2014/main" id="{83905D98-5DDE-FD86-1D83-C9C33B0AB8E9}"/>
+              </a:ext>
+            </a:extLst>
+          </p:cNvPr>
+          <p:cNvPicPr>
+            <a:picLocks noChangeAspect="1"/>
+          </p:cNvPicPr>
+          <p:nvPr/>
+        </p:nvPicPr>
+        <p:blipFill>
+          <a:blip r:embed="rId4"/>
+          <a:stretch>
+            <a:fillRect/>
+          </a:stretch>
+        </p:blipFill>
+        <p:spPr>
+          <a:xfrm>
+            <a:off x="4670322" y="3780177"/>
+            <a:ext cx="3731998" cy="2428875"/>
+          </a:xfrm>
+          <a:prstGeom prst="rect">
+            <a:avLst/>
+          </a:prstGeom>
+        </p:spPr>
+      </p:pic>
     </p:spTree>
+    <p:extLst>
+      <p:ext uri="{BB962C8B-B14F-4D97-AF65-F5344CB8AC3E}">
+        <p14:creationId xmlns:p14="http://schemas.microsoft.com/office/powerpoint/2010/main" val="1609471055"/>
+      </p:ext>
+    </p:extLst>
   </p:cSld>
   <p:clrMapOvr>
     <a:masterClrMapping/>
@@ -6536,64 +6803,42 @@
           <a:chExt cx="0" cy="0"/>
         </a:xfrm>
       </p:grpSpPr>
-      <p:sp>
-        <p:nvSpPr>
-          <p:cNvPr id="2" name="Title 1"/>
-          <p:cNvSpPr>
-            <a:spLocks noGrp="1"/>
-          </p:cNvSpPr>
-          <p:nvPr>
-            <p:ph type="title"/>
-          </p:nvPr>
-        </p:nvSpPr>
-        <p:spPr/>
-        <p:txBody>
-          <a:bodyPr/>
-          <a:lstStyle/>
-          <a:p>
-            <a:r>
-              <a:t>Conclusion</a:t>
-            </a:r>
-          </a:p>
-        </p:txBody>
-      </p:sp>
-      <p:sp>
-        <p:nvSpPr>
-          <p:cNvPr id="3" name="Content Placeholder 2"/>
-          <p:cNvSpPr>
-            <a:spLocks noGrp="1"/>
-          </p:cNvSpPr>
-          <p:nvPr>
-            <p:ph idx="1"/>
-          </p:nvPr>
-        </p:nvSpPr>
-        <p:spPr/>
-        <p:txBody>
-          <a:bodyPr/>
-          <a:lstStyle/>
-          <a:p>
-            <a:r>
-              <a:rPr dirty="0"/>
-              <a:t>• Converts data into insights</a:t>
-            </a:r>
-          </a:p>
-          <a:p>
-            <a:r>
-              <a:rPr dirty="0"/>
-              <a:t>• Improves placement </a:t>
-            </a:r>
-            <a:r>
-              <a:rPr dirty="0" err="1"/>
-              <a:t>readines</a:t>
-            </a:r>
-            <a:r>
-              <a:rPr lang="en-IN" dirty="0"/>
-              <a:t>s</a:t>
-            </a:r>
-          </a:p>
-        </p:txBody>
-      </p:sp>
+      <p:pic>
+        <p:nvPicPr>
+          <p:cNvPr id="3" name="Picture 2">
+            <a:extLst>
+              <a:ext uri="{FF2B5EF4-FFF2-40B4-BE49-F238E27FC236}">
+                <a16:creationId xmlns:a16="http://schemas.microsoft.com/office/drawing/2014/main" id="{9E6D646A-9C1D-D572-26C2-19F845A217E7}"/>
+              </a:ext>
+            </a:extLst>
+          </p:cNvPr>
+          <p:cNvPicPr>
+            <a:picLocks noChangeAspect="1"/>
+          </p:cNvPicPr>
+          <p:nvPr/>
+        </p:nvPicPr>
+        <p:blipFill>
+          <a:blip r:embed="rId2"/>
+          <a:stretch>
+            <a:fillRect/>
+          </a:stretch>
+        </p:blipFill>
+        <p:spPr>
+          <a:xfrm>
+            <a:off x="639097" y="636330"/>
+            <a:ext cx="7815490" cy="5469502"/>
+          </a:xfrm>
+          <a:prstGeom prst="rect">
+            <a:avLst/>
+          </a:prstGeom>
+        </p:spPr>
+      </p:pic>
     </p:spTree>
+    <p:extLst>
+      <p:ext uri="{BB962C8B-B14F-4D97-AF65-F5344CB8AC3E}">
+        <p14:creationId xmlns:p14="http://schemas.microsoft.com/office/powerpoint/2010/main" val="1722855111"/>
+      </p:ext>
+    </p:extLst>
   </p:cSld>
   <p:clrMapOvr>
     <a:masterClrMapping/>

</xml_diff>